<commit_message>
Anonymise forest cooperative in public docs; add 50 kWe fuel-demand calc
Replace the cooperative's name (MitsueMori / 御杖村森林組合 / Mitsue Village
Forest Association) with "Local Forestry Partner" / 地域林業パートナー at the
partner's request. Generic wording in brochures, intro papers, stakeholder
overview and funding deck. Regenerate affected PDFs. Add 50 kWe prototype
CHP 24h fuel-demand calculation (md + pdf). Add Ao Bara/Morita and
Assembly chair to people register (lease signed 2026-09-24).

Co-Authored-By: Claude Sonnet 5.5 <noreply@anthropic.com>
</commit_message>
<xml_diff>
--- a/decks/Mitsue Project Presentation.pptx
+++ b/decks/Mitsue Project Presentation.pptx
@@ -2440,7 +2440,7 @@
                 </a:solidFill>
                 <a:latin typeface="Arial"/>
               </a:rPr>
-              <a:t>Where we are today, September 2026. Phase 0, intentionally quiet. Meetings with the Vice Mayor, the Forest Cooperative, Mitsue Kanko, and more trees/Tenkawa are done. The charter, implementation plan, and EVM plan are drafted. A GX地域共創 decarbonization subsidy inquiry is submitted. T</a:t>
+              <a:t>Where we are today, September 2026. Phase 0, intentionally quiet. Meetings with the Vice Mayor, a local forestry partner, Mitsue Kanko, and more trees/Tenkawa are done. The charter, implementation plan, and EVM plan are drafted. A GX地域共創 decarbonization subsidy inquiry is submitted. T</a:t>
             </a:r>
             <a:r>
               <a:rPr lang="en-US" sz="2000" b="0" u="none" strike="noStrike">
@@ -19912,7 +19912,7 @@
                 <a:latin typeface="Arial"/>
                 <a:ea typeface="Arial"/>
               </a:rPr>
-              <a:t>Mitsue Kanko, Forest Cooperative, more trees/Tenkawa meetings (May–Aug 2026)</a:t>
+              <a:t>Mitsue Kanko, local forestry partner, more trees/Tenkawa meetings (May–Aug 2026)</a:t>
             </a:r>
             <a:endParaRPr lang="en-US" sz="1800" b="0" u="none" strike="noStrike">
               <a:solidFill>

</xml_diff>